<commit_message>
Harmonize typographic hierarchy and spatial alignment across all slides in defense presentation
</commit_message>
<xml_diff>
--- a/中期答辩_精修版.pptx
+++ b/中期答辩_精修版.pptx
@@ -5566,7 +5566,7 @@
         </p:nvSpPr>
         <p:spPr>
           <a:xfrm>
-            <a:off x="914400" y="731520"/>
+            <a:off x="900000" y="720000"/>
             <a:ext cx="7315200" cy="188976"/>
           </a:xfrm>
           <a:prstGeom prst="rect">
@@ -5647,8 +5647,8 @@
         </p:nvSpPr>
         <p:spPr>
           <a:xfrm>
-            <a:off x="914400" y="1078992"/>
-            <a:ext cx="10362895" cy="522732"/>
+            <a:off x="900000" y="1080000"/>
+            <a:ext cx="10368000" cy="540000"/>
           </a:xfrm>
           <a:prstGeom prst="rect">
             <a:avLst/>
@@ -5667,7 +5667,7 @@
               </a:lnSpc>
             </a:pPr>
             <a:r>
-              <a:rPr sz="2900" b="1" i="0">
+              <a:rPr sz="2800" b="1" i="0">
                 <a:solidFill>
                   <a:srgbClr val="1A2030"/>
                 </a:solidFill>
@@ -6537,7 +6537,7 @@
         </p:nvSpPr>
         <p:spPr>
           <a:xfrm>
-            <a:off x="914400" y="868680"/>
+            <a:off x="900000" y="720000"/>
             <a:ext cx="7315200" cy="188976"/>
           </a:xfrm>
           <a:prstGeom prst="rect">
@@ -6618,8 +6618,8 @@
         </p:nvSpPr>
         <p:spPr>
           <a:xfrm>
-            <a:off x="914400" y="1280160"/>
-            <a:ext cx="10362895" cy="544830"/>
+            <a:off x="900000" y="1080000"/>
+            <a:ext cx="10368000" cy="540000"/>
           </a:xfrm>
           <a:prstGeom prst="rect">
             <a:avLst/>
@@ -6638,7 +6638,7 @@
               </a:lnSpc>
             </a:pPr>
             <a:r>
-              <a:rPr sz="2900" b="1" i="0">
+              <a:rPr sz="2800" b="1" i="0">
                 <a:solidFill>
                   <a:srgbClr val="E2DCD0"/>
                 </a:solidFill>
@@ -6659,8 +6659,8 @@
         </p:nvSpPr>
         <p:spPr>
           <a:xfrm>
-            <a:off x="914400" y="2327910"/>
-            <a:ext cx="10362895" cy="12700"/>
+            <a:off x="900000" y="2340000"/>
+            <a:ext cx="10368000" cy="2700000"/>
           </a:xfrm>
           <a:prstGeom prst="rect">
             <a:avLst/>
@@ -6691,7 +6691,11 @@
           <a:bodyPr rtlCol="0" anchor="ctr" wrap="square"/>
           <a:lstStyle/>
           <a:p>
-            <a:pPr algn="ctr"/>
+            <a:pPr algn="ctr">
+              <a:lnSpc>
+                <a:spcPct val="135000"/>
+              </a:lnSpc>
+            </a:pPr>
           </a:p>
         </p:txBody>
       </p:sp>
@@ -6703,8 +6707,8 @@
         </p:nvSpPr>
         <p:spPr>
           <a:xfrm>
-            <a:off x="914400" y="2602230"/>
-            <a:ext cx="8778240" cy="2101088"/>
+            <a:off x="900000" y="2340000"/>
+            <a:ext cx="10368000" cy="2700000"/>
           </a:xfrm>
           <a:prstGeom prst="rect">
             <a:avLst/>
@@ -6719,14 +6723,14 @@
           <a:p>
             <a:pPr indent="-256032" marL="256032">
               <a:lnSpc>
-                <a:spcPct val="160000"/>
+                <a:spcPct val="135000"/>
               </a:lnSpc>
               <a:spcAft>
                 <a:spcPts val="0"/>
               </a:spcAft>
             </a:pPr>
             <a:r>
-              <a:rPr sz="1700">
+              <a:rPr sz="1600" b="0">
                 <a:solidFill>
                   <a:srgbClr val="C8A870"/>
                 </a:solidFill>
@@ -6737,7 +6741,7 @@
               <a:t>— </a:t>
             </a:r>
             <a:r>
-              <a:rPr sz="1700">
+              <a:rPr sz="1600" b="0">
                 <a:solidFill>
                   <a:srgbClr val="E2DCD0"/>
                 </a:solidFill>
@@ -6751,7 +6755,7 @@
           <a:p>
             <a:pPr indent="-256032" marL="256032">
               <a:lnSpc>
-                <a:spcPct val="160000"/>
+                <a:spcPct val="135000"/>
               </a:lnSpc>
               <a:spcBef>
                 <a:spcPts val="1600"/>
@@ -6761,7 +6765,7 @@
               </a:spcAft>
             </a:pPr>
             <a:r>
-              <a:rPr sz="1700">
+              <a:rPr sz="1600" b="0">
                 <a:solidFill>
                   <a:srgbClr val="C8A870"/>
                 </a:solidFill>
@@ -6772,7 +6776,7 @@
               <a:t>— </a:t>
             </a:r>
             <a:r>
-              <a:rPr sz="1700">
+              <a:rPr sz="1600" b="0">
                 <a:solidFill>
                   <a:srgbClr val="E2DCD0"/>
                 </a:solidFill>
@@ -6786,7 +6790,7 @@
           <a:p>
             <a:pPr indent="-256032" marL="256032">
               <a:lnSpc>
-                <a:spcPct val="160000"/>
+                <a:spcPct val="135000"/>
               </a:lnSpc>
               <a:spcBef>
                 <a:spcPts val="1600"/>
@@ -6796,7 +6800,7 @@
               </a:spcAft>
             </a:pPr>
             <a:r>
-              <a:rPr sz="1700">
+              <a:rPr sz="1600" b="0">
                 <a:solidFill>
                   <a:srgbClr val="C8A870"/>
                 </a:solidFill>
@@ -6807,7 +6811,7 @@
               <a:t>— </a:t>
             </a:r>
             <a:r>
-              <a:rPr sz="1700">
+              <a:rPr sz="1600" b="0">
                 <a:solidFill>
                   <a:srgbClr val="E2DCD0"/>
                 </a:solidFill>
@@ -7315,7 +7319,7 @@
         </p:nvSpPr>
         <p:spPr>
           <a:xfrm>
-            <a:off x="914400" y="731520"/>
+            <a:off x="900000" y="720000"/>
             <a:ext cx="7315200" cy="188976"/>
           </a:xfrm>
           <a:prstGeom prst="rect">
@@ -7396,8 +7400,8 @@
         </p:nvSpPr>
         <p:spPr>
           <a:xfrm>
-            <a:off x="914400" y="1078992"/>
-            <a:ext cx="10362895" cy="522732"/>
+            <a:off x="900000" y="1080000"/>
+            <a:ext cx="10368000" cy="540000"/>
           </a:xfrm>
           <a:prstGeom prst="rect">
             <a:avLst/>
@@ -7416,7 +7420,7 @@
               </a:lnSpc>
             </a:pPr>
             <a:r>
-              <a:rPr sz="2900" b="1" i="0">
+              <a:rPr sz="2800" b="1" i="0">
                 <a:solidFill>
                   <a:srgbClr val="1A2030"/>
                 </a:solidFill>
@@ -8029,7 +8033,7 @@
         </p:nvSpPr>
         <p:spPr>
           <a:xfrm>
-            <a:off x="914400" y="731520"/>
+            <a:off x="900000" y="720000"/>
             <a:ext cx="7315200" cy="188976"/>
           </a:xfrm>
           <a:prstGeom prst="rect">
@@ -8110,8 +8114,8 @@
         </p:nvSpPr>
         <p:spPr>
           <a:xfrm>
-            <a:off x="914400" y="1078992"/>
-            <a:ext cx="10362895" cy="522732"/>
+            <a:off x="900000" y="1080000"/>
+            <a:ext cx="10368000" cy="540000"/>
           </a:xfrm>
           <a:prstGeom prst="rect">
             <a:avLst/>
@@ -8130,7 +8134,7 @@
               </a:lnSpc>
             </a:pPr>
             <a:r>
-              <a:rPr sz="2900" b="1" i="0">
+              <a:rPr sz="2800" b="1" i="0">
                 <a:solidFill>
                   <a:srgbClr val="1A2030"/>
                 </a:solidFill>
@@ -9310,7 +9314,7 @@
         </p:nvSpPr>
         <p:spPr>
           <a:xfrm>
-            <a:off x="914400" y="731520"/>
+            <a:off x="900000" y="720000"/>
             <a:ext cx="7315200" cy="188976"/>
           </a:xfrm>
           <a:prstGeom prst="rect">
@@ -9391,8 +9395,8 @@
         </p:nvSpPr>
         <p:spPr>
           <a:xfrm>
-            <a:off x="914400" y="1078992"/>
-            <a:ext cx="10362895" cy="522732"/>
+            <a:off x="900000" y="1080000"/>
+            <a:ext cx="10368000" cy="540000"/>
           </a:xfrm>
           <a:prstGeom prst="rect">
             <a:avLst/>
@@ -9411,7 +9415,7 @@
               </a:lnSpc>
             </a:pPr>
             <a:r>
-              <a:rPr sz="2900" b="1" i="0">
+              <a:rPr sz="2800" b="1" i="0">
                 <a:solidFill>
                   <a:srgbClr val="1A2030"/>
                 </a:solidFill>
@@ -9457,8 +9461,8 @@
         </p:nvSpPr>
         <p:spPr>
           <a:xfrm>
-            <a:off x="914400" y="4600956"/>
-            <a:ext cx="10362895" cy="204216"/>
+            <a:off x="900000" y="4644000"/>
+            <a:ext cx="10368000" cy="216000"/>
           </a:xfrm>
           <a:prstGeom prst="rect">
             <a:avLst/>
@@ -9473,7 +9477,7 @@
           <a:p>
             <a:pPr algn="l"/>
             <a:r>
-              <a:rPr sz="1100" b="0" i="0">
+              <a:rPr sz="1050" b="0" i="0">
                 <a:solidFill>
                   <a:srgbClr val="5A6270"/>
                 </a:solidFill>
@@ -9494,8 +9498,8 @@
         </p:nvSpPr>
         <p:spPr>
           <a:xfrm>
-            <a:off x="914400" y="4930140"/>
-            <a:ext cx="3210458" cy="12700"/>
+            <a:off x="900000" y="4968000"/>
+            <a:ext cx="3204000" cy="198000"/>
           </a:xfrm>
           <a:prstGeom prst="rect">
             <a:avLst/>
@@ -9538,8 +9542,8 @@
         </p:nvSpPr>
         <p:spPr>
           <a:xfrm>
-            <a:off x="914400" y="4930140"/>
-            <a:ext cx="228600" cy="12700"/>
+            <a:off x="900000" y="4968000"/>
+            <a:ext cx="3204000" cy="198000"/>
           </a:xfrm>
           <a:prstGeom prst="rect">
             <a:avLst/>
@@ -9582,8 +9586,8 @@
         </p:nvSpPr>
         <p:spPr>
           <a:xfrm>
-            <a:off x="914400" y="5021580"/>
-            <a:ext cx="3210458" cy="188976"/>
+            <a:off x="900000" y="4968000"/>
+            <a:ext cx="3204000" cy="198000"/>
           </a:xfrm>
           <a:prstGeom prst="rect">
             <a:avLst/>
@@ -9598,7 +9602,7 @@
           <a:p>
             <a:pPr algn="l"/>
             <a:r>
-              <a:rPr sz="1000" b="0" i="0">
+              <a:rPr sz="1200" b="1" i="0">
                 <a:solidFill>
                   <a:srgbClr val="5A6270"/>
                 </a:solidFill>
@@ -9619,8 +9623,8 @@
         </p:nvSpPr>
         <p:spPr>
           <a:xfrm>
-            <a:off x="914400" y="5241036"/>
-            <a:ext cx="3210458" cy="964692"/>
+            <a:off x="900000" y="5220000"/>
+            <a:ext cx="3204000" cy="972000"/>
           </a:xfrm>
           <a:prstGeom prst="rect">
             <a:avLst/>
@@ -9635,11 +9639,11 @@
           <a:p>
             <a:pPr algn="l">
               <a:lnSpc>
-                <a:spcPct val="145000"/>
+                <a:spcPct val="120000"/>
               </a:lnSpc>
             </a:pPr>
             <a:r>
-              <a:rPr sz="1400" b="0" i="0">
+              <a:rPr sz="1200" b="0" i="0">
                 <a:solidFill>
                   <a:srgbClr val="1A2030"/>
                 </a:solidFill>
@@ -9660,8 +9664,8 @@
         </p:nvSpPr>
         <p:spPr>
           <a:xfrm>
-            <a:off x="4490618" y="4930140"/>
-            <a:ext cx="3210458" cy="12700"/>
+            <a:off x="4500000" y="4968000"/>
+            <a:ext cx="3204000" cy="198000"/>
           </a:xfrm>
           <a:prstGeom prst="rect">
             <a:avLst/>
@@ -9704,8 +9708,8 @@
         </p:nvSpPr>
         <p:spPr>
           <a:xfrm>
-            <a:off x="4490618" y="4930140"/>
-            <a:ext cx="228600" cy="12700"/>
+            <a:off x="4500000" y="4968000"/>
+            <a:ext cx="3204000" cy="198000"/>
           </a:xfrm>
           <a:prstGeom prst="rect">
             <a:avLst/>
@@ -9748,8 +9752,8 @@
         </p:nvSpPr>
         <p:spPr>
           <a:xfrm>
-            <a:off x="4490618" y="5021580"/>
-            <a:ext cx="3210458" cy="188976"/>
+            <a:off x="4500000" y="4968000"/>
+            <a:ext cx="3204000" cy="198000"/>
           </a:xfrm>
           <a:prstGeom prst="rect">
             <a:avLst/>
@@ -9764,7 +9768,7 @@
           <a:p>
             <a:pPr algn="l"/>
             <a:r>
-              <a:rPr sz="1000" b="0" i="0">
+              <a:rPr sz="1200" b="1" i="0">
                 <a:solidFill>
                   <a:srgbClr val="5A6270"/>
                 </a:solidFill>
@@ -9785,8 +9789,8 @@
         </p:nvSpPr>
         <p:spPr>
           <a:xfrm>
-            <a:off x="4490618" y="5241036"/>
-            <a:ext cx="3210458" cy="655320"/>
+            <a:off x="4500000" y="5220000"/>
+            <a:ext cx="3204000" cy="972000"/>
           </a:xfrm>
           <a:prstGeom prst="rect">
             <a:avLst/>
@@ -9801,11 +9805,11 @@
           <a:p>
             <a:pPr algn="l">
               <a:lnSpc>
-                <a:spcPct val="145000"/>
+                <a:spcPct val="120000"/>
               </a:lnSpc>
             </a:pPr>
             <a:r>
-              <a:rPr sz="1400" b="0" i="0">
+              <a:rPr sz="1200" b="0" i="0">
                 <a:solidFill>
                   <a:srgbClr val="1A2030"/>
                 </a:solidFill>
@@ -9826,8 +9830,8 @@
         </p:nvSpPr>
         <p:spPr>
           <a:xfrm>
-            <a:off x="8066836" y="4930140"/>
-            <a:ext cx="3210458" cy="12700"/>
+            <a:off x="8063999" y="4968000"/>
+            <a:ext cx="3204000" cy="198000"/>
           </a:xfrm>
           <a:prstGeom prst="rect">
             <a:avLst/>
@@ -9870,8 +9874,8 @@
         </p:nvSpPr>
         <p:spPr>
           <a:xfrm>
-            <a:off x="8066836" y="4930140"/>
-            <a:ext cx="228600" cy="12700"/>
+            <a:off x="8063999" y="4968000"/>
+            <a:ext cx="3204000" cy="198000"/>
           </a:xfrm>
           <a:prstGeom prst="rect">
             <a:avLst/>
@@ -9914,8 +9918,8 @@
         </p:nvSpPr>
         <p:spPr>
           <a:xfrm>
-            <a:off x="8066836" y="5021580"/>
-            <a:ext cx="3210458" cy="188976"/>
+            <a:off x="8063999" y="4968000"/>
+            <a:ext cx="3204000" cy="198000"/>
           </a:xfrm>
           <a:prstGeom prst="rect">
             <a:avLst/>
@@ -9930,7 +9934,7 @@
           <a:p>
             <a:pPr algn="l"/>
             <a:r>
-              <a:rPr sz="1000" b="0" i="0">
+              <a:rPr sz="1200" b="1" i="0">
                 <a:solidFill>
                   <a:srgbClr val="5A6270"/>
                 </a:solidFill>
@@ -9951,8 +9955,8 @@
         </p:nvSpPr>
         <p:spPr>
           <a:xfrm>
-            <a:off x="8066836" y="5241036"/>
-            <a:ext cx="3210458" cy="964692"/>
+            <a:off x="8063999" y="5220000"/>
+            <a:ext cx="3204000" cy="972000"/>
           </a:xfrm>
           <a:prstGeom prst="rect">
             <a:avLst/>
@@ -9967,11 +9971,11 @@
           <a:p>
             <a:pPr algn="l">
               <a:lnSpc>
-                <a:spcPct val="145000"/>
+                <a:spcPct val="120000"/>
               </a:lnSpc>
             </a:pPr>
             <a:r>
-              <a:rPr sz="1400" b="0" i="0">
+              <a:rPr sz="1200" b="0" i="0">
                 <a:solidFill>
                   <a:srgbClr val="1A2030"/>
                 </a:solidFill>
@@ -10254,7 +10258,7 @@
         </p:nvSpPr>
         <p:spPr>
           <a:xfrm>
-            <a:off x="914400" y="731520"/>
+            <a:off x="900000" y="720000"/>
             <a:ext cx="7315200" cy="188976"/>
           </a:xfrm>
           <a:prstGeom prst="rect">
@@ -10335,8 +10339,8 @@
         </p:nvSpPr>
         <p:spPr>
           <a:xfrm>
-            <a:off x="914400" y="1078992"/>
-            <a:ext cx="10362895" cy="522732"/>
+            <a:off x="900000" y="1080000"/>
+            <a:ext cx="10368000" cy="540000"/>
           </a:xfrm>
           <a:prstGeom prst="rect">
             <a:avLst/>
@@ -10355,7 +10359,7 @@
               </a:lnSpc>
             </a:pPr>
             <a:r>
-              <a:rPr sz="2900" b="1" i="0">
+              <a:rPr sz="2800" b="1" i="0">
                 <a:solidFill>
                   <a:srgbClr val="1A2030"/>
                 </a:solidFill>
@@ -10400,8 +10404,8 @@
         </p:nvSpPr>
         <p:spPr>
           <a:xfrm>
-            <a:off x="914400" y="4450409"/>
-            <a:ext cx="10362895" cy="204216"/>
+            <a:off x="900000" y="4644000"/>
+            <a:ext cx="10368000" cy="216000"/>
           </a:xfrm>
           <a:prstGeom prst="rect">
             <a:avLst/>
@@ -10416,7 +10420,7 @@
           <a:p>
             <a:pPr algn="l"/>
             <a:r>
-              <a:rPr>
+              <a:rPr sz="1050" b="0">
                 <a:latin typeface="Times New Roman"/>
                 <a:ea typeface="宋体"/>
               </a:rPr>
@@ -10521,8 +10525,8 @@
         </p:nvSpPr>
         <p:spPr>
           <a:xfrm>
-            <a:off x="914400" y="4956048"/>
-            <a:ext cx="3210458" cy="188976"/>
+            <a:off x="900000" y="4968000"/>
+            <a:ext cx="3204000" cy="198000"/>
           </a:xfrm>
           <a:prstGeom prst="rect">
             <a:avLst/>
@@ -10537,7 +10541,7 @@
           <a:p>
             <a:pPr algn="l"/>
             <a:r>
-              <a:rPr>
+              <a:rPr sz="1200" b="1">
                 <a:latin typeface="Times New Roman"/>
                 <a:ea typeface="宋体"/>
               </a:rPr>
@@ -10666,8 +10670,8 @@
         </p:nvSpPr>
         <p:spPr>
           <a:xfrm>
-            <a:off x="4490618" y="4956048"/>
-            <a:ext cx="3210458" cy="188976"/>
+            <a:off x="4500000" y="4968000"/>
+            <a:ext cx="3204000" cy="198000"/>
           </a:xfrm>
           <a:prstGeom prst="rect">
             <a:avLst/>
@@ -10682,7 +10686,7 @@
           <a:p>
             <a:pPr algn="l"/>
             <a:r>
-              <a:rPr sz="1000" b="0" i="0">
+              <a:rPr sz="1200" b="1" i="0">
                 <a:solidFill>
                   <a:srgbClr val="5A6270"/>
                 </a:solidFill>
@@ -10703,8 +10707,8 @@
         </p:nvSpPr>
         <p:spPr>
           <a:xfrm>
-            <a:off x="4490618" y="5175504"/>
-            <a:ext cx="3210458" cy="655320"/>
+            <a:off x="4500000" y="5220000"/>
+            <a:ext cx="3204000" cy="972000"/>
           </a:xfrm>
           <a:prstGeom prst="rect">
             <a:avLst/>
@@ -10719,11 +10723,11 @@
           <a:p>
             <a:pPr algn="l">
               <a:lnSpc>
-                <a:spcPct val="145000"/>
+                <a:spcPct val="120000"/>
               </a:lnSpc>
             </a:pPr>
             <a:r>
-              <a:rPr sz="1400" b="0" i="0">
+              <a:rPr sz="1200" b="0" i="0">
                 <a:solidFill>
                   <a:srgbClr val="1A2030"/>
                 </a:solidFill>
@@ -10832,8 +10836,8 @@
         </p:nvSpPr>
         <p:spPr>
           <a:xfrm>
-            <a:off x="8066836" y="4956048"/>
-            <a:ext cx="3210458" cy="188976"/>
+            <a:off x="8063999" y="4968000"/>
+            <a:ext cx="3204000" cy="198000"/>
           </a:xfrm>
           <a:prstGeom prst="rect">
             <a:avLst/>
@@ -10848,7 +10852,7 @@
           <a:p>
             <a:pPr algn="l"/>
             <a:r>
-              <a:rPr sz="1000" b="0" i="0">
+              <a:rPr sz="1200" b="1" i="0">
                 <a:solidFill>
                   <a:srgbClr val="5A6270"/>
                 </a:solidFill>
@@ -10869,8 +10873,8 @@
         </p:nvSpPr>
         <p:spPr>
           <a:xfrm>
-            <a:off x="8066836" y="5175504"/>
-            <a:ext cx="3210458" cy="964692"/>
+            <a:off x="8063999" y="5220000"/>
+            <a:ext cx="3204000" cy="972000"/>
           </a:xfrm>
           <a:prstGeom prst="rect">
             <a:avLst/>
@@ -10885,11 +10889,11 @@
           <a:p>
             <a:pPr algn="l">
               <a:lnSpc>
-                <a:spcPct val="145000"/>
+                <a:spcPct val="120000"/>
               </a:lnSpc>
             </a:pPr>
             <a:r>
-              <a:rPr sz="1400" b="0" i="0">
+              <a:rPr sz="1200" b="0" i="0">
                 <a:solidFill>
                   <a:srgbClr val="1A2030"/>
                 </a:solidFill>
@@ -11172,7 +11176,7 @@
         </p:nvSpPr>
         <p:spPr>
           <a:xfrm>
-            <a:off x="914400" y="731520"/>
+            <a:off x="900000" y="720000"/>
             <a:ext cx="7315200" cy="188976"/>
           </a:xfrm>
           <a:prstGeom prst="rect">
@@ -11253,8 +11257,8 @@
         </p:nvSpPr>
         <p:spPr>
           <a:xfrm>
-            <a:off x="914400" y="1078992"/>
-            <a:ext cx="10362895" cy="522732"/>
+            <a:off x="900000" y="1080000"/>
+            <a:ext cx="10368000" cy="540000"/>
           </a:xfrm>
           <a:prstGeom prst="rect">
             <a:avLst/>
@@ -11273,7 +11277,7 @@
               </a:lnSpc>
             </a:pPr>
             <a:r>
-              <a:rPr sz="2900" b="1" i="0">
+              <a:rPr sz="2800" b="1" i="0">
                 <a:solidFill>
                   <a:srgbClr val="1A2030"/>
                 </a:solidFill>
@@ -11318,8 +11322,8 @@
         </p:nvSpPr>
         <p:spPr>
           <a:xfrm>
-            <a:off x="914400" y="4784348"/>
-            <a:ext cx="10362895" cy="204216"/>
+            <a:off x="900000" y="4644000"/>
+            <a:ext cx="10368000" cy="216000"/>
           </a:xfrm>
           <a:prstGeom prst="rect">
             <a:avLst/>
@@ -11334,7 +11338,7 @@
           <a:p>
             <a:pPr algn="l"/>
             <a:r>
-              <a:rPr sz="1100" b="0" i="0">
+              <a:rPr sz="1050" b="0" i="0">
                 <a:solidFill>
                   <a:srgbClr val="5A6270"/>
                 </a:solidFill>
@@ -11355,8 +11359,8 @@
         </p:nvSpPr>
         <p:spPr>
           <a:xfrm>
-            <a:off x="914400" y="5113532"/>
-            <a:ext cx="3210458" cy="12700"/>
+            <a:off x="900000" y="4968000"/>
+            <a:ext cx="3204000" cy="198000"/>
           </a:xfrm>
           <a:prstGeom prst="rect">
             <a:avLst/>
@@ -11399,8 +11403,8 @@
         </p:nvSpPr>
         <p:spPr>
           <a:xfrm>
-            <a:off x="914400" y="5113532"/>
-            <a:ext cx="228600" cy="12700"/>
+            <a:off x="900000" y="4968000"/>
+            <a:ext cx="3204000" cy="198000"/>
           </a:xfrm>
           <a:prstGeom prst="rect">
             <a:avLst/>
@@ -11443,8 +11447,8 @@
         </p:nvSpPr>
         <p:spPr>
           <a:xfrm>
-            <a:off x="914400" y="5204972"/>
-            <a:ext cx="3210458" cy="188976"/>
+            <a:off x="900000" y="4968000"/>
+            <a:ext cx="3204000" cy="198000"/>
           </a:xfrm>
           <a:prstGeom prst="rect">
             <a:avLst/>
@@ -11459,7 +11463,7 @@
           <a:p>
             <a:pPr algn="l"/>
             <a:r>
-              <a:rPr sz="1000" b="0" i="0">
+              <a:rPr sz="1200" b="1" i="0">
                 <a:solidFill>
                   <a:srgbClr val="5A6270"/>
                 </a:solidFill>
@@ -11480,8 +11484,8 @@
         </p:nvSpPr>
         <p:spPr>
           <a:xfrm>
-            <a:off x="914400" y="5424428"/>
-            <a:ext cx="3210458" cy="655320"/>
+            <a:off x="900000" y="5220000"/>
+            <a:ext cx="3204000" cy="972000"/>
           </a:xfrm>
           <a:prstGeom prst="rect">
             <a:avLst/>
@@ -11496,11 +11500,11 @@
           <a:p>
             <a:pPr algn="l">
               <a:lnSpc>
-                <a:spcPct val="145000"/>
+                <a:spcPct val="120000"/>
               </a:lnSpc>
             </a:pPr>
             <a:r>
-              <a:rPr sz="1400" b="0" i="0">
+              <a:rPr sz="1200" b="0" i="0">
                 <a:solidFill>
                   <a:srgbClr val="1A2030"/>
                 </a:solidFill>
@@ -11521,8 +11525,8 @@
         </p:nvSpPr>
         <p:spPr>
           <a:xfrm>
-            <a:off x="4490618" y="5113532"/>
-            <a:ext cx="3210458" cy="12700"/>
+            <a:off x="4500000" y="4968000"/>
+            <a:ext cx="3204000" cy="198000"/>
           </a:xfrm>
           <a:prstGeom prst="rect">
             <a:avLst/>
@@ -11565,8 +11569,8 @@
         </p:nvSpPr>
         <p:spPr>
           <a:xfrm>
-            <a:off x="4490618" y="5113532"/>
-            <a:ext cx="228600" cy="12700"/>
+            <a:off x="4500000" y="4968000"/>
+            <a:ext cx="3204000" cy="198000"/>
           </a:xfrm>
           <a:prstGeom prst="rect">
             <a:avLst/>
@@ -11609,8 +11613,8 @@
         </p:nvSpPr>
         <p:spPr>
           <a:xfrm>
-            <a:off x="4490618" y="5204972"/>
-            <a:ext cx="3210458" cy="188976"/>
+            <a:off x="4500000" y="4968000"/>
+            <a:ext cx="3204000" cy="198000"/>
           </a:xfrm>
           <a:prstGeom prst="rect">
             <a:avLst/>
@@ -11625,7 +11629,7 @@
           <a:p>
             <a:pPr algn="l"/>
             <a:r>
-              <a:rPr sz="1000" b="0" i="0">
+              <a:rPr sz="1200" b="1" i="0">
                 <a:solidFill>
                   <a:srgbClr val="5A6270"/>
                 </a:solidFill>
@@ -11646,8 +11650,8 @@
         </p:nvSpPr>
         <p:spPr>
           <a:xfrm>
-            <a:off x="4490618" y="5424428"/>
-            <a:ext cx="3210458" cy="655320"/>
+            <a:off x="4500000" y="5220000"/>
+            <a:ext cx="3204000" cy="972000"/>
           </a:xfrm>
           <a:prstGeom prst="rect">
             <a:avLst/>
@@ -11662,11 +11666,11 @@
           <a:p>
             <a:pPr algn="l">
               <a:lnSpc>
-                <a:spcPct val="145000"/>
+                <a:spcPct val="120000"/>
               </a:lnSpc>
             </a:pPr>
             <a:r>
-              <a:rPr sz="1400" b="0" i="0">
+              <a:rPr sz="1200" b="0" i="0">
                 <a:solidFill>
                   <a:srgbClr val="1A2030"/>
                 </a:solidFill>
@@ -11687,8 +11691,8 @@
         </p:nvSpPr>
         <p:spPr>
           <a:xfrm>
-            <a:off x="8066836" y="5113532"/>
-            <a:ext cx="3210458" cy="12700"/>
+            <a:off x="8063999" y="4968000"/>
+            <a:ext cx="3204000" cy="198000"/>
           </a:xfrm>
           <a:prstGeom prst="rect">
             <a:avLst/>
@@ -11731,8 +11735,8 @@
         </p:nvSpPr>
         <p:spPr>
           <a:xfrm>
-            <a:off x="8066836" y="5113532"/>
-            <a:ext cx="228600" cy="12700"/>
+            <a:off x="8063999" y="4968000"/>
+            <a:ext cx="3204000" cy="198000"/>
           </a:xfrm>
           <a:prstGeom prst="rect">
             <a:avLst/>
@@ -11775,8 +11779,8 @@
         </p:nvSpPr>
         <p:spPr>
           <a:xfrm>
-            <a:off x="8066836" y="5204972"/>
-            <a:ext cx="3210458" cy="188976"/>
+            <a:off x="8063999" y="4968000"/>
+            <a:ext cx="3204000" cy="198000"/>
           </a:xfrm>
           <a:prstGeom prst="rect">
             <a:avLst/>
@@ -11791,7 +11795,7 @@
           <a:p>
             <a:pPr algn="l"/>
             <a:r>
-              <a:rPr>
+              <a:rPr sz="1200" b="1">
                 <a:latin typeface="Times New Roman"/>
                 <a:ea typeface="宋体"/>
               </a:rPr>
@@ -11808,8 +11812,8 @@
         </p:nvSpPr>
         <p:spPr>
           <a:xfrm>
-            <a:off x="8066836" y="5424428"/>
-            <a:ext cx="3210458" cy="655320"/>
+            <a:off x="8063999" y="5220000"/>
+            <a:ext cx="3204000" cy="972000"/>
           </a:xfrm>
           <a:prstGeom prst="rect">
             <a:avLst/>
@@ -11824,11 +11828,11 @@
           <a:p>
             <a:pPr algn="l">
               <a:lnSpc>
-                <a:spcPct val="145000"/>
+                <a:spcPct val="120000"/>
               </a:lnSpc>
             </a:pPr>
             <a:r>
-              <a:rPr sz="1400" b="0" i="0">
+              <a:rPr sz="1200" b="0" i="0">
                 <a:solidFill>
                   <a:srgbClr val="1A2030"/>
                 </a:solidFill>
@@ -12111,7 +12115,7 @@
         </p:nvSpPr>
         <p:spPr>
           <a:xfrm>
-            <a:off x="914400" y="731520"/>
+            <a:off x="900000" y="720000"/>
             <a:ext cx="7315200" cy="188976"/>
           </a:xfrm>
           <a:prstGeom prst="rect">
@@ -12192,8 +12196,8 @@
         </p:nvSpPr>
         <p:spPr>
           <a:xfrm>
-            <a:off x="914400" y="1078992"/>
-            <a:ext cx="10362895" cy="522732"/>
+            <a:off x="900000" y="1080000"/>
+            <a:ext cx="10368000" cy="540000"/>
           </a:xfrm>
           <a:prstGeom prst="rect">
             <a:avLst/>
@@ -12212,7 +12216,7 @@
               </a:lnSpc>
             </a:pPr>
             <a:r>
-              <a:rPr sz="2900" b="1" i="0">
+              <a:rPr sz="2800" b="1" i="0">
                 <a:solidFill>
                   <a:srgbClr val="1A2030"/>
                 </a:solidFill>
@@ -12257,8 +12261,8 @@
         </p:nvSpPr>
         <p:spPr>
           <a:xfrm>
-            <a:off x="914400" y="4756876"/>
-            <a:ext cx="10362895" cy="204216"/>
+            <a:off x="900000" y="4644000"/>
+            <a:ext cx="10368000" cy="216000"/>
           </a:xfrm>
           <a:prstGeom prst="rect">
             <a:avLst/>
@@ -12273,7 +12277,7 @@
           <a:p>
             <a:pPr algn="l"/>
             <a:r>
-              <a:rPr sz="1100" b="0" i="0">
+              <a:rPr sz="1050" b="0" i="0">
                 <a:solidFill>
                   <a:srgbClr val="5A6270"/>
                 </a:solidFill>
@@ -12294,8 +12298,8 @@
         </p:nvSpPr>
         <p:spPr>
           <a:xfrm>
-            <a:off x="914400" y="5086060"/>
-            <a:ext cx="3210458" cy="12700"/>
+            <a:off x="900000" y="4968000"/>
+            <a:ext cx="3204000" cy="198000"/>
           </a:xfrm>
           <a:prstGeom prst="rect">
             <a:avLst/>
@@ -12338,8 +12342,8 @@
         </p:nvSpPr>
         <p:spPr>
           <a:xfrm>
-            <a:off x="914400" y="5086060"/>
-            <a:ext cx="228600" cy="12700"/>
+            <a:off x="900000" y="4968000"/>
+            <a:ext cx="3204000" cy="198000"/>
           </a:xfrm>
           <a:prstGeom prst="rect">
             <a:avLst/>
@@ -12382,8 +12386,8 @@
         </p:nvSpPr>
         <p:spPr>
           <a:xfrm>
-            <a:off x="914400" y="5177500"/>
-            <a:ext cx="3210458" cy="188976"/>
+            <a:off x="900000" y="4968000"/>
+            <a:ext cx="3204000" cy="198000"/>
           </a:xfrm>
           <a:prstGeom prst="rect">
             <a:avLst/>
@@ -12398,7 +12402,7 @@
           <a:p>
             <a:pPr algn="l"/>
             <a:r>
-              <a:rPr sz="1000" b="0" i="0">
+              <a:rPr sz="1200" b="1" i="0">
                 <a:solidFill>
                   <a:srgbClr val="5A6270"/>
                 </a:solidFill>
@@ -12419,8 +12423,8 @@
         </p:nvSpPr>
         <p:spPr>
           <a:xfrm>
-            <a:off x="914400" y="5396956"/>
-            <a:ext cx="3210458" cy="655320"/>
+            <a:off x="900000" y="5220000"/>
+            <a:ext cx="3204000" cy="972000"/>
           </a:xfrm>
           <a:prstGeom prst="rect">
             <a:avLst/>
@@ -12435,11 +12439,11 @@
           <a:p>
             <a:pPr algn="l">
               <a:lnSpc>
-                <a:spcPct val="145000"/>
+                <a:spcPct val="120000"/>
               </a:lnSpc>
             </a:pPr>
             <a:r>
-              <a:rPr sz="1400" b="0" i="0">
+              <a:rPr sz="1200" b="0" i="0">
                 <a:solidFill>
                   <a:srgbClr val="1A2030"/>
                 </a:solidFill>
@@ -12460,8 +12464,8 @@
         </p:nvSpPr>
         <p:spPr>
           <a:xfrm>
-            <a:off x="4490618" y="5086060"/>
-            <a:ext cx="3210458" cy="12700"/>
+            <a:off x="4500000" y="4968000"/>
+            <a:ext cx="3204000" cy="198000"/>
           </a:xfrm>
           <a:prstGeom prst="rect">
             <a:avLst/>
@@ -12504,8 +12508,8 @@
         </p:nvSpPr>
         <p:spPr>
           <a:xfrm>
-            <a:off x="4490618" y="5086060"/>
-            <a:ext cx="228600" cy="12700"/>
+            <a:off x="4500000" y="4968000"/>
+            <a:ext cx="3204000" cy="198000"/>
           </a:xfrm>
           <a:prstGeom prst="rect">
             <a:avLst/>
@@ -12548,8 +12552,8 @@
         </p:nvSpPr>
         <p:spPr>
           <a:xfrm>
-            <a:off x="4490618" y="5177500"/>
-            <a:ext cx="3210458" cy="188976"/>
+            <a:off x="4500000" y="4968000"/>
+            <a:ext cx="3204000" cy="198000"/>
           </a:xfrm>
           <a:prstGeom prst="rect">
             <a:avLst/>
@@ -12564,7 +12568,7 @@
           <a:p>
             <a:pPr algn="l"/>
             <a:r>
-              <a:rPr sz="1000" b="0" i="0">
+              <a:rPr sz="1200" b="1" i="0">
                 <a:solidFill>
                   <a:srgbClr val="5A6270"/>
                 </a:solidFill>
@@ -12585,8 +12589,8 @@
         </p:nvSpPr>
         <p:spPr>
           <a:xfrm>
-            <a:off x="4490618" y="5396956"/>
-            <a:ext cx="3210458" cy="655320"/>
+            <a:off x="4500000" y="5220000"/>
+            <a:ext cx="3204000" cy="972000"/>
           </a:xfrm>
           <a:prstGeom prst="rect">
             <a:avLst/>
@@ -12601,11 +12605,11 @@
           <a:p>
             <a:pPr algn="l">
               <a:lnSpc>
-                <a:spcPct val="145000"/>
+                <a:spcPct val="120000"/>
               </a:lnSpc>
             </a:pPr>
             <a:r>
-              <a:rPr sz="1400" b="0" i="0">
+              <a:rPr sz="1200" b="0" i="0">
                 <a:solidFill>
                   <a:srgbClr val="1A2030"/>
                 </a:solidFill>
@@ -12626,8 +12630,8 @@
         </p:nvSpPr>
         <p:spPr>
           <a:xfrm>
-            <a:off x="8066836" y="5086060"/>
-            <a:ext cx="3210458" cy="12700"/>
+            <a:off x="8063999" y="4968000"/>
+            <a:ext cx="3204000" cy="198000"/>
           </a:xfrm>
           <a:prstGeom prst="rect">
             <a:avLst/>
@@ -12670,8 +12674,8 @@
         </p:nvSpPr>
         <p:spPr>
           <a:xfrm>
-            <a:off x="8066836" y="5086060"/>
-            <a:ext cx="228600" cy="12700"/>
+            <a:off x="8063999" y="4968000"/>
+            <a:ext cx="3204000" cy="198000"/>
           </a:xfrm>
           <a:prstGeom prst="rect">
             <a:avLst/>
@@ -12714,8 +12718,8 @@
         </p:nvSpPr>
         <p:spPr>
           <a:xfrm>
-            <a:off x="8066836" y="5177500"/>
-            <a:ext cx="3210458" cy="188976"/>
+            <a:off x="8063999" y="4968000"/>
+            <a:ext cx="3204000" cy="198000"/>
           </a:xfrm>
           <a:prstGeom prst="rect">
             <a:avLst/>
@@ -12730,7 +12734,7 @@
           <a:p>
             <a:pPr algn="l"/>
             <a:r>
-              <a:rPr sz="1000" b="0" i="0">
+              <a:rPr sz="1200" b="1" i="0">
                 <a:solidFill>
                   <a:srgbClr val="5A6270"/>
                 </a:solidFill>
@@ -12751,8 +12755,8 @@
         </p:nvSpPr>
         <p:spPr>
           <a:xfrm>
-            <a:off x="8066836" y="5396956"/>
-            <a:ext cx="3210458" cy="655320"/>
+            <a:off x="8063999" y="5220000"/>
+            <a:ext cx="3204000" cy="972000"/>
           </a:xfrm>
           <a:prstGeom prst="rect">
             <a:avLst/>
@@ -12767,11 +12771,11 @@
           <a:p>
             <a:pPr algn="l">
               <a:lnSpc>
-                <a:spcPct val="145000"/>
+                <a:spcPct val="120000"/>
               </a:lnSpc>
             </a:pPr>
             <a:r>
-              <a:rPr sz="1400" b="0" i="0">
+              <a:rPr sz="1200" b="0" i="0">
                 <a:solidFill>
                   <a:srgbClr val="1A2030"/>
                 </a:solidFill>
@@ -13054,7 +13058,7 @@
         </p:nvSpPr>
         <p:spPr>
           <a:xfrm>
-            <a:off x="914400" y="731520"/>
+            <a:off x="900000" y="720000"/>
             <a:ext cx="7315200" cy="188976"/>
           </a:xfrm>
           <a:prstGeom prst="rect">
@@ -13135,8 +13139,8 @@
         </p:nvSpPr>
         <p:spPr>
           <a:xfrm>
-            <a:off x="914400" y="1078992"/>
-            <a:ext cx="10362895" cy="522732"/>
+            <a:off x="900000" y="1080000"/>
+            <a:ext cx="10368000" cy="540000"/>
           </a:xfrm>
           <a:prstGeom prst="rect">
             <a:avLst/>
@@ -13155,7 +13159,7 @@
               </a:lnSpc>
             </a:pPr>
             <a:r>
-              <a:rPr sz="2900" b="1" i="0">
+              <a:rPr sz="2800" b="1" i="0">
                 <a:solidFill>
                   <a:srgbClr val="1A2030"/>
                 </a:solidFill>
@@ -14428,7 +14432,7 @@
         </p:nvSpPr>
         <p:spPr>
           <a:xfrm>
-            <a:off x="914400" y="731520"/>
+            <a:off x="900000" y="720000"/>
             <a:ext cx="7315200" cy="188976"/>
           </a:xfrm>
           <a:prstGeom prst="rect">
@@ -14509,8 +14513,8 @@
         </p:nvSpPr>
         <p:spPr>
           <a:xfrm>
-            <a:off x="914400" y="1078992"/>
-            <a:ext cx="10362895" cy="522732"/>
+            <a:off x="900000" y="1080000"/>
+            <a:ext cx="10368000" cy="540000"/>
           </a:xfrm>
           <a:prstGeom prst="rect">
             <a:avLst/>
@@ -14529,7 +14533,7 @@
               </a:lnSpc>
             </a:pPr>
             <a:r>
-              <a:rPr sz="2900" b="1" i="0">
+              <a:rPr sz="2800" b="1" i="0">
                 <a:solidFill>
                   <a:srgbClr val="1A2030"/>
                 </a:solidFill>

</xml_diff>